<commit_message>
Add real team names to all documents
EBODE ADA ERIKA ALEXANDRA (ICTU20233909) — Team Leader
AJA CHELLA ASAMBA JR (ICTU20233787) — Developer & DevOps

Updated: FINAL_REPORT.md, README.md, SCRUM_REPORT.md,
all 4 Word document cover pages, PPTX title slide
</commit_message>
<xml_diff>
--- a/MindBridge_Presentation.pptx
+++ b/MindBridge_Presentation.pptx
@@ -3527,10 +3527,8 @@
                 </a:solidFill>
                 <a:latin typeface="Arial"/>
               </a:rPr>
-              <a:t>Member 1 — Backend &amp; Testing
-Member 2 — Frontend &amp; UX
-Member 3 — DevOps &amp; Infrastructure
-Member 4 — Documentation &amp; Scrum</a:t>
+              <a:t>EBODE ADA ERIKA ALEXANDRA  (ICTU20233909)  —  Team Leader
+AJA CHELLA ASAMBA JR  (ICTU20233787)  —  Developer &amp; DevOps</a:t>
             </a:r>
           </a:p>
         </p:txBody>

</xml_diff>